<commit_message>
Ship verified testnet orders and tamper-proof demo
</commit_message>
<xml_diff>
--- a/output/Orca-Orders-pitch.pptx
+++ b/output/Orca-Orders-pitch.pptx
@@ -2,18 +2,18 @@
 <file path=ppt/presentation.xml><?xml version="1.0" encoding="utf-8"?>
 <p:presentation xmlns:p="http://schemas.openxmlformats.org/presentationml/2006/main">
   <p:sldMasterIdLst>
-    <p:sldMasterId xmlns:r="http://schemas.openxmlformats.org/officeDocument/2006/relationships" id="2147483648" r:id="R7257152f006d4094"/>
+    <p:sldMasterId xmlns:r="http://schemas.openxmlformats.org/officeDocument/2006/relationships" id="2147483648" r:id="R5cb55a0e97be4b6b"/>
   </p:sldMasterIdLst>
   <p:notesMasterIdLst>
-    <p:notesMasterId xmlns:r="http://schemas.openxmlformats.org/officeDocument/2006/relationships" r:id="Ra76da32ea8164d48"/>
+    <p:notesMasterId xmlns:r="http://schemas.openxmlformats.org/officeDocument/2006/relationships" r:id="R778885a81009417c"/>
   </p:notesMasterIdLst>
   <p:sldIdLst>
-    <p:sldId xmlns:r="http://schemas.openxmlformats.org/officeDocument/2006/relationships" id="256" r:id="Ra170f2fcd26f4260"/>
-    <p:sldId xmlns:r="http://schemas.openxmlformats.org/officeDocument/2006/relationships" id="257" r:id="R805ca48ec3264538"/>
-    <p:sldId xmlns:r="http://schemas.openxmlformats.org/officeDocument/2006/relationships" id="258" r:id="R92c10c8c98bc4796"/>
-    <p:sldId xmlns:r="http://schemas.openxmlformats.org/officeDocument/2006/relationships" id="259" r:id="R914288e072ff4387"/>
-    <p:sldId xmlns:r="http://schemas.openxmlformats.org/officeDocument/2006/relationships" id="260" r:id="R2d002bdf36654a64"/>
-    <p:sldId xmlns:r="http://schemas.openxmlformats.org/officeDocument/2006/relationships" id="261" r:id="R480b706e0f0e43e7"/>
+    <p:sldId xmlns:r="http://schemas.openxmlformats.org/officeDocument/2006/relationships" id="256" r:id="R07a726825ffe49b0"/>
+    <p:sldId xmlns:r="http://schemas.openxmlformats.org/officeDocument/2006/relationships" id="257" r:id="R81b5adbcf6204a05"/>
+    <p:sldId xmlns:r="http://schemas.openxmlformats.org/officeDocument/2006/relationships" id="258" r:id="R9aaa0bc9d7bf405c"/>
+    <p:sldId xmlns:r="http://schemas.openxmlformats.org/officeDocument/2006/relationships" id="259" r:id="R13e8e70c4b274ac2"/>
+    <p:sldId xmlns:r="http://schemas.openxmlformats.org/officeDocument/2006/relationships" id="260" r:id="R238ca584934846ea"/>
+    <p:sldId xmlns:r="http://schemas.openxmlformats.org/officeDocument/2006/relationships" id="261" r:id="R09eee1de98ac4f47"/>
   </p:sldIdLst>
   <p:sldSz cx="12192000" cy="6858000"/>
   <p:notesSz cx="6858000" cy="9144000"/>
@@ -447,7 +447,7 @@
           <a:lstStyle xmlns:a="http://schemas.openxmlformats.org/drawingml/2006/main"/>
           <a:p xmlns:a="http://schemas.openxmlformats.org/drawingml/2006/main">
             <a:r>
-              <a:t>Orca Labs — TOKEN2049 Origins 2026. Open with the need for bounded agent spending and independently verified results. This deck accompanies the implemented rehearsal. Actual sponsor execution remains pending. Never present the rehearsal as deployed chain activity.</a:t>
+              <a:t>Orca Labs — TOKEN2049 Origins 2026. Open with the need for bounded agent spending and independently verified results. Three actual testnet orders now settled across all four partners. The movie tours their recorded proof plus a clearly labeled local tamper replay. There is no production DON.</a:t>
             </a:r>
           </a:p>
         </p:txBody>
@@ -587,7 +587,7 @@
           <a:lstStyle xmlns:a="http://schemas.openxmlformats.org/drawingml/2006/main"/>
           <a:p xmlns:a="http://schemas.openxmlformats.org/drawingml/2006/main">
             <a:r>
-              <a:t>Play the embedded 52.7-second rehearsal recording on this slide. It was captured from the actual local interface in success, tampered-report and expiry/refund scenarios. Idle time between clips is removed; no assets move, and no sponsor executions are shown. Speak over the clip: immutable budget, reserved quote, seller signature, independent verification, rejection, refund. The movie is embedded in PPTX; playback in legacy PPT and the actual stage player must still be verified.</a:t>
+              <a:t>Play the embedded 48-second edited proof tour. Authentic app screenshots show an actual settled testnet order, six NOWNodes facts and ten successful official CRE checks. Paced still holds present the local replay: one fee changes by +1, signature stays valid, integrity/provenance fail, then restore passes. No new payment occurs during this recording. The first two orders required operator recovery after parsing/upstream errors, without duplicate purchases. A separate genuine 90-second direct program expiry probe refunded 0.01 tSOL; the product UI keeps 15 minutes. Native stage playback and exact format remain unverified.</a:t>
             </a:r>
           </a:p>
         </p:txBody>
@@ -657,7 +657,7 @@
           <a:lstStyle xmlns:a="http://schemas.openxmlformats.org/drawingml/2006/main"/>
           <a:p xmlns:a="http://schemas.openxmlformats.org/drawingml/2006/main">
             <a:r>
-              <a:t>Integration source: docs/ARCHITECTURE.md and implemented adapters. Event track pages: https://builderbase.com/track/solana-best-use-of-solana ; https://builderbase.com/track/cardano-agentic-commerce ; https://builderbase.com/track/chainlink-best-workflow-with-cre ; https://builderbase.com/track/nownodes-multichain-infrastructure-challenge . This describes implemented live architecture, not completed sponsor execution. CRE independently reads escrow and payment plus NOWNodes facts. The prototype uses a local simulation and trusted relayer, not a production DON.</a:t>
+              <a:t>Integration source: docs/ARCHITECTURE.md and implemented adapters. Event track pages: https://builderbase.com/track/solana-best-use-of-solana ; https://builderbase.com/track/cardano-agentic-commerce ; https://builderbase.com/track/chainlink-best-workflow-with-cre ; https://builderbase.com/track/nownodes-multichain-infrastructure-challenge . All four integrations executed in three genuine settled testnet orders. CRE independently reads escrow and payment plus NOWNodes facts. The prototype uses a local simulation and trusted relayer, not a production DON.</a:t>
             </a:r>
           </a:p>
         </p:txBody>
@@ -727,7 +727,7 @@
           <a:lstStyle xmlns:a="http://schemas.openxmlformats.org/drawingml/2006/main"/>
           <a:p xmlns:a="http://schemas.openxmlformats.org/drawingml/2006/main">
             <a:r>
-              <a:t>29 tests passed on 6 October 2026. They include compiled Solana ELF execution in LiteSVM and CRE verifier fixture tests. The native program compiled using Solana Playground; CRE compiled to WebAssembly with the official SDK/Javy compiler. This is not deployed program evidence or a successful CRE CLI simulation. NOWNodes €15 credit was redeemed but plan/API activation is pending. Cardano preprod wallet funding and Blockfrost key are pending. No actual live integration, transaction hashes, or user traction are claimed. See docs/evidence/STATUS.md.</a:t>
+              <a:t>36 tests pass, including compiled ELF LiteSVM, CRE fixture reads, full CLI result parsing and portable cryptographic tamper replay. Solana Devnet program deployed with exact binary read-back. Three actual Cardano preprod x402 payments, NOWNodes Solana/Cardano reports, ten accepted official CRE checks per order and actual Solana reward settlements. Separate genuine expiry refund returns 0.01 tSOL. The operator retains upgrade authority; the demo uses local CRE simulation and a trusted relayer. Source/judge access, durable hosting and stage playback remain gates. See docs/evidence/STATUS.md.</a:t>
             </a:r>
           </a:p>
         </p:txBody>
@@ -797,7 +797,7 @@
           <a:lstStyle xmlns:a="http://schemas.openxmlformats.org/drawingml/2006/main"/>
           <a:p xmlns:a="http://schemas.openxmlformats.org/drawingml/2006/main">
             <a:r>
-              <a:t>Business model hypothesis only: per-task execution/verification fee or team subscription. No paying customers or interview findings are claimed. First validation: speak to blockchain ops teams about reporting errors, budget approvals and audit needs. Prioritize one genuine end-to-end execution before scope expansion. Deadline verified in event dashboard: 7 October 2026 23:59 Singapore / 17:59 Berlin. Internal target 22:00 Singapore / 16:00 Berlin. Stage deck should contain the recorded technical demo rather than a live technical demo. https://builderbase.com/event/token2049-origins-hackathon</a:t>
+              <a:t>Business model hypothesis only: per-task execution/verification fee or team subscription. No paying customers or interview findings are claimed. First validation: speak to blockchain ops teams about reporting errors, budget approvals and audit needs. Actual sponsor execution and expiry refund now pass. Freeze scope and finish judging access, hosting, stage format and playback. Deadline verified in event dashboard: 7 October 2026 23:59 Singapore / 17:59 Berlin. Internal target 22:00 Singapore / 16:00 Berlin. Stage deck should contain the recorded technical demo rather than a live technical demo. https://builderbase.com/event/token2049-origins-hackathon</a:t>
             </a:r>
           </a:p>
         </p:txBody>
@@ -865,7 +865,7 @@
   </p:cSld>
   <p:clrMap bg1="lt1" tx1="dk1" bg2="lt2" tx2="dk2" accent1="accent1" accent2="accent2" accent3="accent3" accent4="accent4" accent5="accent5" accent6="accent6" hlink="hlink" folHlink="folHlink"/>
   <p:sldLayoutIdLst>
-    <p:sldLayoutId xmlns:r="http://schemas.openxmlformats.org/officeDocument/2006/relationships" id="2147483649" r:id="R3503fd4ed32f43df"/>
+    <p:sldLayoutId xmlns:r="http://schemas.openxmlformats.org/officeDocument/2006/relationships" id="2147483649" r:id="Rf7bef71b045c47a3"/>
   </p:sldLayoutIdLst>
   <p:txStyles>
     <p:titleStyle>
@@ -1416,7 +1416,7 @@
           <p:cNvPr id="5" name="">
             <a:extLst xmlns:a="http://schemas.openxmlformats.org/drawingml/2006/main">
               <a:ext uri="{FF2B5EF4-FFF2-40B4-BE49-F238E27FC236}">
-                <a16:creationId xmlns:a16="http://schemas.microsoft.com/office/drawing/2014/main" id="{339915A8-463B-4B38-B023-39DF15667C58}"/>
+                <a16:creationId xmlns:a16="http://schemas.microsoft.com/office/drawing/2014/main" id="{538F21B6-BDDA-4D8E-9937-E14E32D4D7CB}"/>
               </a:ext>
             </a:extLst>
           </p:cNvPr>
@@ -1473,7 +1473,7 @@
           <p:cNvPr id="2" name="">
             <a:extLst xmlns:a="http://schemas.openxmlformats.org/drawingml/2006/main">
               <a:ext uri="{FF2B5EF4-FFF2-40B4-BE49-F238E27FC236}">
-                <a16:creationId xmlns:a16="http://schemas.microsoft.com/office/drawing/2014/main" id="{AE0AA3E2-9F3F-4B35-85AA-0FC7485D0A9B}"/>
+                <a16:creationId xmlns:a16="http://schemas.microsoft.com/office/drawing/2014/main" id="{FAF04FD1-55D1-4E81-BD9F-117B7243D06D}"/>
               </a:ext>
             </a:extLst>
           </p:cNvPr>
@@ -1553,7 +1553,7 @@
           <p:cNvPr id="3" name="">
             <a:extLst xmlns:a="http://schemas.openxmlformats.org/drawingml/2006/main">
               <a:ext uri="{FF2B5EF4-FFF2-40B4-BE49-F238E27FC236}">
-                <a16:creationId xmlns:a16="http://schemas.microsoft.com/office/drawing/2014/main" id="{6D5E47A7-1DF0-477C-971D-882FCF30EDE3}"/>
+                <a16:creationId xmlns:a16="http://schemas.microsoft.com/office/drawing/2014/main" id="{BBC96288-A012-4342-9757-3CCA310720B4}"/>
               </a:ext>
             </a:extLst>
           </p:cNvPr>
@@ -1633,7 +1633,7 @@
           <p:cNvPr id="4" name="">
             <a:extLst xmlns:a="http://schemas.openxmlformats.org/drawingml/2006/main">
               <a:ext uri="{FF2B5EF4-FFF2-40B4-BE49-F238E27FC236}">
-                <a16:creationId xmlns:a16="http://schemas.microsoft.com/office/drawing/2014/main" id="{0C0D7CB7-CA95-4544-964E-39224934DB0A}"/>
+                <a16:creationId xmlns:a16="http://schemas.microsoft.com/office/drawing/2014/main" id="{580B5300-08F4-49E9-A93A-0A10AE1ACD4A}"/>
               </a:ext>
             </a:extLst>
           </p:cNvPr>
@@ -1645,7 +1645,7 @@
         <p:spPr>
           <a:xfrm xmlns:a="http://schemas.openxmlformats.org/drawingml/2006/main">
             <a:off x="609600" y="6057900"/>
-            <a:ext cx="8572500" cy="333375"/>
+            <a:ext cx="8572500" cy="342900"/>
           </a:xfrm>
           <a:prstGeom xmlns:a="http://schemas.openxmlformats.org/drawingml/2006/main" prst="rect">
             <a:avLst/>
@@ -1688,7 +1688,7 @@
     </p:spTree>
     <p:extLst>
       <p:ext uri="{BB962C8B-B14F-4D97-AF65-F5344CB8AC3E}">
-        <p14:creationId xmlns:p14="http://schemas.microsoft.com/office/powerpoint/2010/main" val="2060831620"/>
+        <p14:creationId xmlns:p14="http://schemas.microsoft.com/office/powerpoint/2010/main" val="1384025080"/>
       </p:ext>
     </p:extLst>
   </p:cSld>
@@ -1719,7 +1719,7 @@
           <p:cNvPr id="13" name="">
             <a:extLst xmlns:a="http://schemas.openxmlformats.org/drawingml/2006/main">
               <a:ext uri="{FF2B5EF4-FFF2-40B4-BE49-F238E27FC236}">
-                <a16:creationId xmlns:a16="http://schemas.microsoft.com/office/drawing/2014/main" id="{4E6788E8-3070-48CD-8A50-4E2B0DC71C83}"/>
+                <a16:creationId xmlns:a16="http://schemas.microsoft.com/office/drawing/2014/main" id="{994BC27E-F40F-4BD4-92CA-33C69B557165}"/>
               </a:ext>
             </a:extLst>
           </p:cNvPr>
@@ -1776,7 +1776,7 @@
           <p:cNvPr id="2" name="">
             <a:extLst xmlns:a="http://schemas.openxmlformats.org/drawingml/2006/main">
               <a:ext uri="{FF2B5EF4-FFF2-40B4-BE49-F238E27FC236}">
-                <a16:creationId xmlns:a16="http://schemas.microsoft.com/office/drawing/2014/main" id="{983AC833-5478-4AE4-B4CA-8D35565DC865}"/>
+                <a16:creationId xmlns:a16="http://schemas.microsoft.com/office/drawing/2014/main" id="{94909EB1-A88F-4C81-A2A5-413250412872}"/>
               </a:ext>
             </a:extLst>
           </p:cNvPr>
@@ -1788,7 +1788,7 @@
         <p:spPr>
           <a:xfrm xmlns:a="http://schemas.openxmlformats.org/drawingml/2006/main">
             <a:off x="609600" y="1676400"/>
-            <a:ext cx="10477500" cy="1285875"/>
+            <a:ext cx="10477500" cy="1295400"/>
           </a:xfrm>
           <a:prstGeom xmlns:a="http://schemas.openxmlformats.org/drawingml/2006/main" prst="rect">
             <a:avLst/>
@@ -1856,7 +1856,7 @@
           <p:cNvPr id="3" name="">
             <a:extLst xmlns:a="http://schemas.openxmlformats.org/drawingml/2006/main">
               <a:ext uri="{FF2B5EF4-FFF2-40B4-BE49-F238E27FC236}">
-                <a16:creationId xmlns:a16="http://schemas.microsoft.com/office/drawing/2014/main" id="{B15CBCBE-EFBF-4A5E-9666-ABC7D0060248}"/>
+                <a16:creationId xmlns:a16="http://schemas.microsoft.com/office/drawing/2014/main" id="{52E9B6A6-FBB0-4761-A971-08580C497508}"/>
               </a:ext>
             </a:extLst>
           </p:cNvPr>
@@ -1867,7 +1867,7 @@
         </p:nvSpPr>
         <p:spPr>
           <a:xfrm xmlns:a="http://schemas.openxmlformats.org/drawingml/2006/main">
-            <a:off x="609600" y="3352800"/>
+            <a:off x="609600" y="3448050"/>
             <a:ext cx="714375" cy="571500"/>
           </a:xfrm>
           <a:prstGeom xmlns:a="http://schemas.openxmlformats.org/drawingml/2006/main" prst="rect">
@@ -1913,7 +1913,7 @@
           <p:cNvPr id="4" name="">
             <a:extLst xmlns:a="http://schemas.openxmlformats.org/drawingml/2006/main">
               <a:ext uri="{FF2B5EF4-FFF2-40B4-BE49-F238E27FC236}">
-                <a16:creationId xmlns:a16="http://schemas.microsoft.com/office/drawing/2014/main" id="{7CB1F8D4-4534-4461-837E-6E96110AD7C1}"/>
+                <a16:creationId xmlns:a16="http://schemas.microsoft.com/office/drawing/2014/main" id="{D6C36F95-68DD-43A3-9B0F-79FB1EAF14A4}"/>
               </a:ext>
             </a:extLst>
           </p:cNvPr>
@@ -1924,7 +1924,7 @@
         </p:nvSpPr>
         <p:spPr>
           <a:xfrm xmlns:a="http://schemas.openxmlformats.org/drawingml/2006/main">
-            <a:off x="1571625" y="3352800"/>
+            <a:off x="1571625" y="3448050"/>
             <a:ext cx="3429000" cy="571500"/>
           </a:xfrm>
           <a:prstGeom xmlns:a="http://schemas.openxmlformats.org/drawingml/2006/main" prst="rect">
@@ -1970,7 +1970,7 @@
           <p:cNvPr id="5" name="">
             <a:extLst xmlns:a="http://schemas.openxmlformats.org/drawingml/2006/main">
               <a:ext uri="{FF2B5EF4-FFF2-40B4-BE49-F238E27FC236}">
-                <a16:creationId xmlns:a16="http://schemas.microsoft.com/office/drawing/2014/main" id="{D8AD6E94-DC7C-4BF2-A1A2-F76D1138DCA9}"/>
+                <a16:creationId xmlns:a16="http://schemas.microsoft.com/office/drawing/2014/main" id="{5B4F757C-9ABC-49A4-970D-CE60FBABAB69}"/>
               </a:ext>
             </a:extLst>
           </p:cNvPr>
@@ -1981,7 +1981,7 @@
         </p:nvSpPr>
         <p:spPr>
           <a:xfrm xmlns:a="http://schemas.openxmlformats.org/drawingml/2006/main">
-            <a:off x="5334000" y="3352800"/>
+            <a:off x="5334000" y="3448050"/>
             <a:ext cx="6191250" cy="809625"/>
           </a:xfrm>
           <a:prstGeom xmlns:a="http://schemas.openxmlformats.org/drawingml/2006/main" prst="rect">
@@ -2027,7 +2027,7 @@
           <p:cNvPr id="6" name="">
             <a:extLst xmlns:a="http://schemas.openxmlformats.org/drawingml/2006/main">
               <a:ext uri="{FF2B5EF4-FFF2-40B4-BE49-F238E27FC236}">
-                <a16:creationId xmlns:a16="http://schemas.microsoft.com/office/drawing/2014/main" id="{C99EE098-364B-4DB3-86E7-8CB3F465D75D}"/>
+                <a16:creationId xmlns:a16="http://schemas.microsoft.com/office/drawing/2014/main" id="{36FE2B17-0BDA-49E1-8E13-1426F55B2054}"/>
               </a:ext>
             </a:extLst>
           </p:cNvPr>
@@ -2038,7 +2038,7 @@
         </p:nvSpPr>
         <p:spPr>
           <a:xfrm xmlns:a="http://schemas.openxmlformats.org/drawingml/2006/main">
-            <a:off x="609600" y="4257675"/>
+            <a:off x="609600" y="4352925"/>
             <a:ext cx="714375" cy="571500"/>
           </a:xfrm>
           <a:prstGeom xmlns:a="http://schemas.openxmlformats.org/drawingml/2006/main" prst="rect">
@@ -2084,7 +2084,7 @@
           <p:cNvPr id="7" name="">
             <a:extLst xmlns:a="http://schemas.openxmlformats.org/drawingml/2006/main">
               <a:ext uri="{FF2B5EF4-FFF2-40B4-BE49-F238E27FC236}">
-                <a16:creationId xmlns:a16="http://schemas.microsoft.com/office/drawing/2014/main" id="{AF3C072C-CC5E-4940-ACC2-13EBBE1989DF}"/>
+                <a16:creationId xmlns:a16="http://schemas.microsoft.com/office/drawing/2014/main" id="{39681A12-7482-4D7F-BC38-4A0A3338B6C1}"/>
               </a:ext>
             </a:extLst>
           </p:cNvPr>
@@ -2095,7 +2095,7 @@
         </p:nvSpPr>
         <p:spPr>
           <a:xfrm xmlns:a="http://schemas.openxmlformats.org/drawingml/2006/main">
-            <a:off x="1571625" y="4257675"/>
+            <a:off x="1571625" y="4352925"/>
             <a:ext cx="3429000" cy="571500"/>
           </a:xfrm>
           <a:prstGeom xmlns:a="http://schemas.openxmlformats.org/drawingml/2006/main" prst="rect">
@@ -2141,7 +2141,7 @@
           <p:cNvPr id="8" name="">
             <a:extLst xmlns:a="http://schemas.openxmlformats.org/drawingml/2006/main">
               <a:ext uri="{FF2B5EF4-FFF2-40B4-BE49-F238E27FC236}">
-                <a16:creationId xmlns:a16="http://schemas.microsoft.com/office/drawing/2014/main" id="{6FFB1952-93BA-4D46-B265-693666821761}"/>
+                <a16:creationId xmlns:a16="http://schemas.microsoft.com/office/drawing/2014/main" id="{1752FE81-5B85-4BAC-AA9E-9D37ED60943D}"/>
               </a:ext>
             </a:extLst>
           </p:cNvPr>
@@ -2152,7 +2152,7 @@
         </p:nvSpPr>
         <p:spPr>
           <a:xfrm xmlns:a="http://schemas.openxmlformats.org/drawingml/2006/main">
-            <a:off x="5334000" y="4257675"/>
+            <a:off x="5334000" y="4352925"/>
             <a:ext cx="6191250" cy="809625"/>
           </a:xfrm>
           <a:prstGeom xmlns:a="http://schemas.openxmlformats.org/drawingml/2006/main" prst="rect">
@@ -2198,7 +2198,7 @@
           <p:cNvPr id="9" name="">
             <a:extLst xmlns:a="http://schemas.openxmlformats.org/drawingml/2006/main">
               <a:ext uri="{FF2B5EF4-FFF2-40B4-BE49-F238E27FC236}">
-                <a16:creationId xmlns:a16="http://schemas.microsoft.com/office/drawing/2014/main" id="{F20E2C85-B583-41CF-A5B0-F2C6D170BD25}"/>
+                <a16:creationId xmlns:a16="http://schemas.microsoft.com/office/drawing/2014/main" id="{3B518992-E5FC-4884-9D43-4BCDA6DB10CF}"/>
               </a:ext>
             </a:extLst>
           </p:cNvPr>
@@ -2209,7 +2209,7 @@
         </p:nvSpPr>
         <p:spPr>
           <a:xfrm xmlns:a="http://schemas.openxmlformats.org/drawingml/2006/main">
-            <a:off x="609600" y="5162550"/>
+            <a:off x="609600" y="5257800"/>
             <a:ext cx="714375" cy="571500"/>
           </a:xfrm>
           <a:prstGeom xmlns:a="http://schemas.openxmlformats.org/drawingml/2006/main" prst="rect">
@@ -2255,7 +2255,7 @@
           <p:cNvPr id="10" name="">
             <a:extLst xmlns:a="http://schemas.openxmlformats.org/drawingml/2006/main">
               <a:ext uri="{FF2B5EF4-FFF2-40B4-BE49-F238E27FC236}">
-                <a16:creationId xmlns:a16="http://schemas.microsoft.com/office/drawing/2014/main" id="{D26C0909-B6D5-4937-82F9-5CDE1BB2807E}"/>
+                <a16:creationId xmlns:a16="http://schemas.microsoft.com/office/drawing/2014/main" id="{45BA04C4-3CD7-4AB5-888E-F15A59FF7C64}"/>
               </a:ext>
             </a:extLst>
           </p:cNvPr>
@@ -2266,7 +2266,7 @@
         </p:nvSpPr>
         <p:spPr>
           <a:xfrm xmlns:a="http://schemas.openxmlformats.org/drawingml/2006/main">
-            <a:off x="1571625" y="5162550"/>
+            <a:off x="1571625" y="5257800"/>
             <a:ext cx="3429000" cy="571500"/>
           </a:xfrm>
           <a:prstGeom xmlns:a="http://schemas.openxmlformats.org/drawingml/2006/main" prst="rect">
@@ -2312,7 +2312,7 @@
           <p:cNvPr id="11" name="">
             <a:extLst xmlns:a="http://schemas.openxmlformats.org/drawingml/2006/main">
               <a:ext uri="{FF2B5EF4-FFF2-40B4-BE49-F238E27FC236}">
-                <a16:creationId xmlns:a16="http://schemas.microsoft.com/office/drawing/2014/main" id="{1E23B351-B079-4320-924F-6FB9154EC390}"/>
+                <a16:creationId xmlns:a16="http://schemas.microsoft.com/office/drawing/2014/main" id="{184012A2-628B-464D-9D66-67F7DC29FF83}"/>
               </a:ext>
             </a:extLst>
           </p:cNvPr>
@@ -2323,7 +2323,7 @@
         </p:nvSpPr>
         <p:spPr>
           <a:xfrm xmlns:a="http://schemas.openxmlformats.org/drawingml/2006/main">
-            <a:off x="5334000" y="5162550"/>
+            <a:off x="5334000" y="5257800"/>
             <a:ext cx="6191250" cy="809625"/>
           </a:xfrm>
           <a:prstGeom xmlns:a="http://schemas.openxmlformats.org/drawingml/2006/main" prst="rect">
@@ -2369,7 +2369,7 @@
           <p:cNvPr id="12" name="">
             <a:extLst xmlns:a="http://schemas.openxmlformats.org/drawingml/2006/main">
               <a:ext uri="{FF2B5EF4-FFF2-40B4-BE49-F238E27FC236}">
-                <a16:creationId xmlns:a16="http://schemas.microsoft.com/office/drawing/2014/main" id="{57B1E7AC-F54A-4D44-B7F4-2FE54ECED7BE}"/>
+                <a16:creationId xmlns:a16="http://schemas.microsoft.com/office/drawing/2014/main" id="{24B89AD1-9B85-4B49-8EBD-D6E14815D715}"/>
               </a:ext>
             </a:extLst>
           </p:cNvPr>
@@ -2381,7 +2381,7 @@
         <p:spPr>
           <a:xfrm xmlns:a="http://schemas.openxmlformats.org/drawingml/2006/main">
             <a:off x="609600" y="6229350"/>
-            <a:ext cx="10953750" cy="333375"/>
+            <a:ext cx="10953750" cy="342900"/>
           </a:xfrm>
           <a:prstGeom xmlns:a="http://schemas.openxmlformats.org/drawingml/2006/main" prst="rect">
             <a:avLst/>
@@ -2424,7 +2424,7 @@
     </p:spTree>
     <p:extLst>
       <p:ext uri="{BB962C8B-B14F-4D97-AF65-F5344CB8AC3E}">
-        <p14:creationId xmlns:p14="http://schemas.microsoft.com/office/powerpoint/2010/main" val="2118412426"/>
+        <p14:creationId xmlns:p14="http://schemas.microsoft.com/office/powerpoint/2010/main" val="1004145174"/>
       </p:ext>
     </p:extLst>
   </p:cSld>
@@ -2455,7 +2455,7 @@
           <p:cNvPr id="7" name="">
             <a:extLst>
               <a:ext uri="{FF2B5EF4-FFF2-40B4-BE49-F238E27FC236}">
-                <ns2:creationId id="{241A82EB-40B6-49CB-A0A8-4E1F040B6824}"/>
+                <ns2:creationId id="{8B297D4E-6909-4AED-B99D-FA8C75C9DE5F}"/>
               </a:ext>
             </a:extLst>
           </p:cNvPr>
@@ -2512,7 +2512,7 @@
           <p:cNvPr id="2" name="">
             <a:extLst>
               <a:ext uri="{FF2B5EF4-FFF2-40B4-BE49-F238E27FC236}">
-                <ns2:creationId id="{34B46F0F-611D-46D8-9EFB-3CDA30B75CD8}"/>
+                <ns2:creationId id="{3CB9A78E-CC47-4E94-9C0A-A16673AC69F5}"/>
               </a:ext>
             </a:extLst>
           </p:cNvPr>
@@ -2559,14 +2559,14 @@
                 <a:ea typeface="Arial"/>
                 <a:cs typeface="Arial"/>
               </a:rPr>
-              <a:t>Recorded rehearsal · sample data · no assets moved</a:t>
+              <a:t>Actual testnet proof · local tamper replay</a:t>
             </a:r>
           </a:p>
         </p:txBody>
       </p:sp>
       <p:pic>
         <p:nvPicPr>
-          <p:cNvPr id="9" name="Orca Orders recorded rehearsal">
+          <p:cNvPr id="9" name="Orca Orders testnet proof tour">
             <a:hlinkClick action="ppaction://media"/>
           </p:cNvPr>
           <p:cNvPicPr>
@@ -2582,13 +2582,13 @@
           </p:nvPr>
         </p:nvPicPr>
         <p:blipFill>
-          <a:blip r:embed="Rb602b80126804c0e"/>
+          <a:blip r:embed="Rd4c2ad29f08b46b4"/>
           <a:stretch/>
         </p:blipFill>
         <p:spPr>
           <a:xfrm>
-            <a:off x="610658" y="1924050"/>
-            <a:ext cx="8094133" cy="4552950"/>
+            <a:off x="1622425" y="1924050"/>
+            <a:ext cx="6070600" cy="4552950"/>
           </a:xfrm>
           <a:prstGeom prst="rect">
             <a:avLst/>
@@ -2600,7 +2600,7 @@
           <p:cNvPr id="4" name="">
             <a:extLst>
               <a:ext uri="{FF2B5EF4-FFF2-40B4-BE49-F238E27FC236}">
-                <ns2:creationId id="{21926BBC-A1DD-4CF5-B702-6D0FDADA5D99}"/>
+                <ns2:creationId id="{D7D6B862-757A-4446-AD05-438E6BC9EA2D}"/>
               </a:ext>
             </a:extLst>
           </p:cNvPr>
@@ -2647,7 +2647,7 @@
                 <a:ea typeface="Arial"/>
                 <a:cs typeface="Arial"/>
               </a:rPr>
-              <a:t>Success</a:t>
+              <a:t>Real proof</a:t>
             </a:r>
           </a:p>
           <a:p>
@@ -2670,7 +2670,7 @@
                 <a:ea typeface="Arial"/>
                 <a:cs typeface="Arial"/>
               </a:rPr>
-              <a:t>Reward released after checks.</a:t>
+              <a:t>Three paid orders settled.</a:t>
             </a:r>
           </a:p>
         </p:txBody>
@@ -2680,7 +2680,7 @@
           <p:cNvPr id="5" name="">
             <a:extLst>
               <a:ext uri="{FF2B5EF4-FFF2-40B4-BE49-F238E27FC236}">
-                <ns2:creationId id="{7660B729-D919-412A-A083-9DE0E5B9686E}"/>
+                <ns2:creationId id="{5ADFDBD1-249D-48E6-A3B4-D6C76971668B}"/>
               </a:ext>
             </a:extLst>
           </p:cNvPr>
@@ -2727,7 +2727,7 @@
                 <a:ea typeface="Arial"/>
                 <a:cs typeface="Arial"/>
               </a:rPr>
-              <a:t>Tampering</a:t>
+              <a:t>One fee +1</a:t>
             </a:r>
           </a:p>
           <a:p>
@@ -2750,7 +2750,7 @@
                 <a:ea typeface="Arial"/>
                 <a:cs typeface="Arial"/>
               </a:rPr>
-              <a:t>Changed facts are rejected.</a:t>
+              <a:t>Valid signature; rejected facts.</a:t>
             </a:r>
           </a:p>
         </p:txBody>
@@ -2760,7 +2760,7 @@
           <p:cNvPr id="6" name="">
             <a:extLst>
               <a:ext uri="{FF2B5EF4-FFF2-40B4-BE49-F238E27FC236}">
-                <ns2:creationId id="{A3C9122E-153C-4F70-A4DD-91ABE31B6E05}"/>
+                <ns2:creationId id="{8F40ABB0-E243-4328-A4B3-3753FE7B4669}"/>
               </a:ext>
             </a:extLst>
           </p:cNvPr>
@@ -2771,7 +2771,7 @@
         </p:nvSpPr>
         <p:spPr>
           <a:xfrm>
-            <a:off x="9048750" y="5095875"/>
+            <a:off x="9048750" y="5105400"/>
             <a:ext cx="2571750" cy="1047750"/>
           </a:xfrm>
           <a:prstGeom prst="rect">
@@ -2807,7 +2807,7 @@
                 <a:ea typeface="Arial"/>
                 <a:cs typeface="Arial"/>
               </a:rPr>
-              <a:t>Expiry</a:t>
+              <a:t>Restore</a:t>
             </a:r>
           </a:p>
           <a:p>
@@ -2830,7 +2830,7 @@
                 <a:ea typeface="Arial"/>
                 <a:cs typeface="Arial"/>
               </a:rPr>
-              <a:t>Buyer reward is refunded.</a:t>
+              <a:t>Saved proof passes again.</a:t>
             </a:r>
           </a:p>
         </p:txBody>
@@ -2838,7 +2838,7 @@
     </p:spTree>
     <p:extLst>
       <p:ext uri="{BB962C8B-B14F-4D97-AF65-F5344CB8AC3E}">
-        <p14:creationId val="1832176850"/>
+        <p14:creationId val="145090753"/>
       </p:ext>
     </p:extLst>
   </p:cSld>
@@ -2891,7 +2891,7 @@
           <p:cNvPr id="12" name="">
             <a:extLst xmlns:a="http://schemas.openxmlformats.org/drawingml/2006/main">
               <a:ext uri="{FF2B5EF4-FFF2-40B4-BE49-F238E27FC236}">
-                <a16:creationId xmlns:a16="http://schemas.microsoft.com/office/drawing/2014/main" id="{EFEDCBAA-D88F-45AC-A46C-4E47CC0365A5}"/>
+                <a16:creationId xmlns:a16="http://schemas.microsoft.com/office/drawing/2014/main" id="{17BD18DD-FC0D-479D-8D4A-4014C02A0D76}"/>
               </a:ext>
             </a:extLst>
           </p:cNvPr>
@@ -2948,7 +2948,7 @@
           <p:cNvPr id="2" name="">
             <a:extLst xmlns:a="http://schemas.openxmlformats.org/drawingml/2006/main">
               <a:ext uri="{FF2B5EF4-FFF2-40B4-BE49-F238E27FC236}">
-                <a16:creationId xmlns:a16="http://schemas.microsoft.com/office/drawing/2014/main" id="{9FE5C98F-A993-4A96-A3E8-D1CFEF877203}"/>
+                <a16:creationId xmlns:a16="http://schemas.microsoft.com/office/drawing/2014/main" id="{5EC0FDEE-0B65-43EF-93BE-51864CAA7A91}"/>
               </a:ext>
             </a:extLst>
           </p:cNvPr>
@@ -3005,7 +3005,7 @@
           <p:cNvPr id="3" name="">
             <a:extLst xmlns:a="http://schemas.openxmlformats.org/drawingml/2006/main">
               <a:ext uri="{FF2B5EF4-FFF2-40B4-BE49-F238E27FC236}">
-                <a16:creationId xmlns:a16="http://schemas.microsoft.com/office/drawing/2014/main" id="{2F7A5702-91F7-4124-A9A3-E52E653E720F}"/>
+                <a16:creationId xmlns:a16="http://schemas.microsoft.com/office/drawing/2014/main" id="{C36D3C22-2C78-4572-AA62-AFC97609A736}"/>
               </a:ext>
             </a:extLst>
           </p:cNvPr>
@@ -3062,7 +3062,7 @@
           <p:cNvPr id="4" name="">
             <a:extLst xmlns:a="http://schemas.openxmlformats.org/drawingml/2006/main">
               <a:ext uri="{FF2B5EF4-FFF2-40B4-BE49-F238E27FC236}">
-                <a16:creationId xmlns:a16="http://schemas.microsoft.com/office/drawing/2014/main" id="{76A11D2C-2537-4821-91D4-110FFDA8FF84}"/>
+                <a16:creationId xmlns:a16="http://schemas.microsoft.com/office/drawing/2014/main" id="{05DA7DBC-CBCB-4B1A-B968-11E5163EB15F}"/>
               </a:ext>
             </a:extLst>
           </p:cNvPr>
@@ -3119,7 +3119,7 @@
           <p:cNvPr id="5" name="">
             <a:extLst xmlns:a="http://schemas.openxmlformats.org/drawingml/2006/main">
               <a:ext uri="{FF2B5EF4-FFF2-40B4-BE49-F238E27FC236}">
-                <a16:creationId xmlns:a16="http://schemas.microsoft.com/office/drawing/2014/main" id="{4918EC85-01B1-41F8-BADD-BCF557751772}"/>
+                <a16:creationId xmlns:a16="http://schemas.microsoft.com/office/drawing/2014/main" id="{D0741ACE-2022-4792-92FF-6E0BB736601A}"/>
               </a:ext>
             </a:extLst>
           </p:cNvPr>
@@ -3176,7 +3176,7 @@
           <p:cNvPr id="6" name="">
             <a:extLst xmlns:a="http://schemas.openxmlformats.org/drawingml/2006/main">
               <a:ext uri="{FF2B5EF4-FFF2-40B4-BE49-F238E27FC236}">
-                <a16:creationId xmlns:a16="http://schemas.microsoft.com/office/drawing/2014/main" id="{8A2C7C59-E21D-4916-9797-3A17BD0AA23D}"/>
+                <a16:creationId xmlns:a16="http://schemas.microsoft.com/office/drawing/2014/main" id="{20FB524A-C071-4E06-9087-BF771F344CEF}"/>
               </a:ext>
             </a:extLst>
           </p:cNvPr>
@@ -3233,7 +3233,7 @@
           <p:cNvPr id="7" name="">
             <a:extLst xmlns:a="http://schemas.openxmlformats.org/drawingml/2006/main">
               <a:ext uri="{FF2B5EF4-FFF2-40B4-BE49-F238E27FC236}">
-                <a16:creationId xmlns:a16="http://schemas.microsoft.com/office/drawing/2014/main" id="{FA330EAC-7B45-4248-88DD-CC4F96E7E278}"/>
+                <a16:creationId xmlns:a16="http://schemas.microsoft.com/office/drawing/2014/main" id="{A392DCFE-F040-4E47-9E37-E0CFE4CFECC2}"/>
               </a:ext>
             </a:extLst>
           </p:cNvPr>
@@ -3290,7 +3290,7 @@
           <p:cNvPr id="8" name="">
             <a:extLst xmlns:a="http://schemas.openxmlformats.org/drawingml/2006/main">
               <a:ext uri="{FF2B5EF4-FFF2-40B4-BE49-F238E27FC236}">
-                <a16:creationId xmlns:a16="http://schemas.microsoft.com/office/drawing/2014/main" id="{B9BD9DC2-54F5-4CF6-B486-181ECB0A6BF6}"/>
+                <a16:creationId xmlns:a16="http://schemas.microsoft.com/office/drawing/2014/main" id="{C79C7F97-FBD6-4D05-A6E8-9CD8B6D6F909}"/>
               </a:ext>
             </a:extLst>
           </p:cNvPr>
@@ -3347,7 +3347,7 @@
           <p:cNvPr id="9" name="">
             <a:extLst xmlns:a="http://schemas.openxmlformats.org/drawingml/2006/main">
               <a:ext uri="{FF2B5EF4-FFF2-40B4-BE49-F238E27FC236}">
-                <a16:creationId xmlns:a16="http://schemas.microsoft.com/office/drawing/2014/main" id="{068E99DD-2534-4B9B-9E01-10B5A5342299}"/>
+                <a16:creationId xmlns:a16="http://schemas.microsoft.com/office/drawing/2014/main" id="{BB78C6D1-C2C4-40E7-A9F4-6726E6388EEF}"/>
               </a:ext>
             </a:extLst>
           </p:cNvPr>
@@ -3404,7 +3404,7 @@
           <p:cNvPr id="10" name="">
             <a:extLst xmlns:a="http://schemas.openxmlformats.org/drawingml/2006/main">
               <a:ext uri="{FF2B5EF4-FFF2-40B4-BE49-F238E27FC236}">
-                <a16:creationId xmlns:a16="http://schemas.microsoft.com/office/drawing/2014/main" id="{F486C826-561C-40FE-9185-87CB2BC909AB}"/>
+                <a16:creationId xmlns:a16="http://schemas.microsoft.com/office/drawing/2014/main" id="{3AD1DF9C-FE41-40CA-895D-CB8DB5385AC4}"/>
               </a:ext>
             </a:extLst>
           </p:cNvPr>
@@ -3461,7 +3461,7 @@
           <p:cNvPr id="11" name="">
             <a:extLst xmlns:a="http://schemas.openxmlformats.org/drawingml/2006/main">
               <a:ext uri="{FF2B5EF4-FFF2-40B4-BE49-F238E27FC236}">
-                <a16:creationId xmlns:a16="http://schemas.microsoft.com/office/drawing/2014/main" id="{4B3AC576-B072-45A9-9C10-3FEEE17B4B53}"/>
+                <a16:creationId xmlns:a16="http://schemas.microsoft.com/office/drawing/2014/main" id="{E34A80B2-E503-4408-88B3-B93B6CAD7AB7}"/>
               </a:ext>
             </a:extLst>
           </p:cNvPr>
@@ -3516,7 +3516,7 @@
     </p:spTree>
     <p:extLst>
       <p:ext uri="{BB962C8B-B14F-4D97-AF65-F5344CB8AC3E}">
-        <p14:creationId xmlns:p14="http://schemas.microsoft.com/office/powerpoint/2010/main" val="420851476"/>
+        <p14:creationId xmlns:p14="http://schemas.microsoft.com/office/powerpoint/2010/main" val="751354175"/>
       </p:ext>
     </p:extLst>
   </p:cSld>
@@ -3547,7 +3547,7 @@
           <p:cNvPr id="10" name="">
             <a:extLst xmlns:a="http://schemas.openxmlformats.org/drawingml/2006/main">
               <a:ext uri="{FF2B5EF4-FFF2-40B4-BE49-F238E27FC236}">
-                <a16:creationId xmlns:a16="http://schemas.microsoft.com/office/drawing/2014/main" id="{55DC9FCB-D910-4D22-991C-AA242125EC7C}"/>
+                <a16:creationId xmlns:a16="http://schemas.microsoft.com/office/drawing/2014/main" id="{EB2DB604-05B2-458B-88F5-20FCCCD4B0FF}"/>
               </a:ext>
             </a:extLst>
           </p:cNvPr>
@@ -3594,7 +3594,7 @@
                 <a:ea typeface="Arial"/>
                 <a:cs typeface="Arial"/>
               </a:rPr>
-              <a:t>Tested locally. Live proof comes next.</a:t>
+              <a:t>Three paid orders. Four proven integrations.</a:t>
             </a:r>
           </a:p>
         </p:txBody>
@@ -3604,7 +3604,7 @@
           <p:cNvPr id="2" name="">
             <a:extLst xmlns:a="http://schemas.openxmlformats.org/drawingml/2006/main">
               <a:ext uri="{FF2B5EF4-FFF2-40B4-BE49-F238E27FC236}">
-                <a16:creationId xmlns:a16="http://schemas.microsoft.com/office/drawing/2014/main" id="{9BD46D70-4B83-44CF-9FC4-5E0A03FA1CBC}"/>
+                <a16:creationId xmlns:a16="http://schemas.microsoft.com/office/drawing/2014/main" id="{939E0315-92B7-4B22-9D4C-7D25EE61126F}"/>
               </a:ext>
             </a:extLst>
           </p:cNvPr>
@@ -3651,7 +3651,7 @@
                 <a:ea typeface="Arial"/>
                 <a:cs typeface="Arial"/>
               </a:rPr>
-              <a:t>29</a:t>
+              <a:t>36</a:t>
             </a:r>
           </a:p>
         </p:txBody>
@@ -3661,7 +3661,7 @@
           <p:cNvPr id="3" name="">
             <a:extLst xmlns:a="http://schemas.openxmlformats.org/drawingml/2006/main">
               <a:ext uri="{FF2B5EF4-FFF2-40B4-BE49-F238E27FC236}">
-                <a16:creationId xmlns:a16="http://schemas.microsoft.com/office/drawing/2014/main" id="{69949116-3549-4D1C-9F61-81EA8816141C}"/>
+                <a16:creationId xmlns:a16="http://schemas.microsoft.com/office/drawing/2014/main" id="{756826B5-9965-4AE5-8581-F99CE31F9C5E}"/>
               </a:ext>
             </a:extLst>
           </p:cNvPr>
@@ -3718,7 +3718,7 @@
           <p:cNvPr id="4" name="">
             <a:extLst xmlns:a="http://schemas.openxmlformats.org/drawingml/2006/main">
               <a:ext uri="{FF2B5EF4-FFF2-40B4-BE49-F238E27FC236}">
-                <a16:creationId xmlns:a16="http://schemas.microsoft.com/office/drawing/2014/main" id="{692BB7B7-6D5D-4AA8-9F2D-A9E12BF229B8}"/>
+                <a16:creationId xmlns:a16="http://schemas.microsoft.com/office/drawing/2014/main" id="{B8BC1185-DC03-4095-AD4E-245798077F23}"/>
               </a:ext>
             </a:extLst>
           </p:cNvPr>
@@ -3765,7 +3765,7 @@
                 <a:ea typeface="Arial"/>
                 <a:cs typeface="Arial"/>
               </a:rPr>
-              <a:t>Escrow VM checks</a:t>
+              <a:t>Escrow VM + CRE fixture checks</a:t>
             </a:r>
           </a:p>
           <a:p xmlns:a="http://schemas.openxmlformats.org/drawingml/2006/main">
@@ -3788,7 +3788,7 @@
                 <a:ea typeface="Arial"/>
                 <a:cs typeface="Arial"/>
               </a:rPr>
-              <a:t>Receipt and payment binding</a:t>
+              <a:t>Signed receipt and report replay</a:t>
             </a:r>
           </a:p>
           <a:p xmlns:a="http://schemas.openxmlformats.org/drawingml/2006/main">
@@ -3811,7 +3811,7 @@
                 <a:ea typeface="Arial"/>
                 <a:cs typeface="Arial"/>
               </a:rPr>
-              <a:t>Tamper rejection and recovery</a:t>
+              <a:t>Parsing and queue recovery</a:t>
             </a:r>
           </a:p>
         </p:txBody>
@@ -3821,7 +3821,7 @@
           <p:cNvPr id="5" name="">
             <a:extLst xmlns:a="http://schemas.openxmlformats.org/drawingml/2006/main">
               <a:ext uri="{FF2B5EF4-FFF2-40B4-BE49-F238E27FC236}">
-                <a16:creationId xmlns:a16="http://schemas.microsoft.com/office/drawing/2014/main" id="{4DE64C43-2D74-403A-BC54-537AF9846C16}"/>
+                <a16:creationId xmlns:a16="http://schemas.microsoft.com/office/drawing/2014/main" id="{75FE1BEA-4BB3-464B-84D8-9889ED20EF02}"/>
               </a:ext>
             </a:extLst>
           </p:cNvPr>
@@ -3868,7 +3868,7 @@
                 <a:ea typeface="Arial"/>
                 <a:cs typeface="Arial"/>
               </a:rPr>
-              <a:t>Compiled artifacts</a:t>
+              <a:t>Actual execution</a:t>
             </a:r>
           </a:p>
         </p:txBody>
@@ -3878,7 +3878,7 @@
           <p:cNvPr id="6" name="">
             <a:extLst xmlns:a="http://schemas.openxmlformats.org/drawingml/2006/main">
               <a:ext uri="{FF2B5EF4-FFF2-40B4-BE49-F238E27FC236}">
-                <a16:creationId xmlns:a16="http://schemas.microsoft.com/office/drawing/2014/main" id="{3B32ABCE-1D1A-43BB-AA3F-806040F9F7A3}"/>
+                <a16:creationId xmlns:a16="http://schemas.microsoft.com/office/drawing/2014/main" id="{DE539243-E0F4-425A-85DD-892927E5102C}"/>
               </a:ext>
             </a:extLst>
           </p:cNvPr>
@@ -3925,7 +3925,7 @@
                 <a:ea typeface="Arial"/>
                 <a:cs typeface="Arial"/>
               </a:rPr>
-              <a:t>Native Solana program · tested in LiteSVM</a:t>
+              <a:t>Three Cardano x402 purchases + Solana rewards</a:t>
             </a:r>
           </a:p>
           <a:p xmlns:a="http://schemas.openxmlformats.org/drawingml/2006/main">
@@ -3948,7 +3948,7 @@
                 <a:ea typeface="Arial"/>
                 <a:cs typeface="Arial"/>
               </a:rPr>
-              <a:t>CRE verification workflow · WebAssembly</a:t>
+              <a:t>10 CRE checks passed on each order</a:t>
             </a:r>
           </a:p>
         </p:txBody>
@@ -3958,7 +3958,7 @@
           <p:cNvPr id="7" name="">
             <a:extLst xmlns:a="http://schemas.openxmlformats.org/drawingml/2006/main">
               <a:ext uri="{FF2B5EF4-FFF2-40B4-BE49-F238E27FC236}">
-                <a16:creationId xmlns:a16="http://schemas.microsoft.com/office/drawing/2014/main" id="{22A92CAF-BDCA-4FD9-A392-08041A6C3101}"/>
+                <a16:creationId xmlns:a16="http://schemas.microsoft.com/office/drawing/2014/main" id="{B5B34DBD-E195-4A36-8299-DB7886B7E9A2}"/>
               </a:ext>
             </a:extLst>
           </p:cNvPr>
@@ -4005,7 +4005,7 @@
                 <a:ea typeface="Arial"/>
                 <a:cs typeface="Arial"/>
               </a:rPr>
-              <a:t>Still required</a:t>
+              <a:t>Failure protection</a:t>
             </a:r>
           </a:p>
         </p:txBody>
@@ -4015,7 +4015,7 @@
           <p:cNvPr id="8" name="">
             <a:extLst xmlns:a="http://schemas.openxmlformats.org/drawingml/2006/main">
               <a:ext uri="{FF2B5EF4-FFF2-40B4-BE49-F238E27FC236}">
-                <a16:creationId xmlns:a16="http://schemas.microsoft.com/office/drawing/2014/main" id="{D7D01C84-9BB4-4842-9688-167FE7D67A6C}"/>
+                <a16:creationId xmlns:a16="http://schemas.microsoft.com/office/drawing/2014/main" id="{0E9EF006-244B-4BDB-A79A-D84491E34B5F}"/>
               </a:ext>
             </a:extLst>
           </p:cNvPr>
@@ -4027,7 +4027,7 @@
         <p:spPr>
           <a:xfrm xmlns:a="http://schemas.openxmlformats.org/drawingml/2006/main">
             <a:off x="5429250" y="4724400"/>
-            <a:ext cx="5905500" cy="1285875"/>
+            <a:ext cx="5905500" cy="1295400"/>
           </a:xfrm>
           <a:prstGeom xmlns:a="http://schemas.openxmlformats.org/drawingml/2006/main" prst="rect">
             <a:avLst/>
@@ -4062,7 +4062,7 @@
                 <a:ea typeface="Arial"/>
                 <a:cs typeface="Arial"/>
               </a:rPr>
-              <a:t>Sponsor API access and CRE login</a:t>
+              <a:t>0.01 tSOL returned after real expiry</a:t>
             </a:r>
           </a:p>
           <a:p xmlns:a="http://schemas.openxmlformats.org/drawingml/2006/main">
@@ -4085,7 +4085,7 @@
                 <a:ea typeface="Arial"/>
                 <a:cs typeface="Arial"/>
               </a:rPr>
-              <a:t>Funded test wallets + actual chain execution</a:t>
+              <a:t>One-fee replay catches altered facts</a:t>
             </a:r>
           </a:p>
           <a:p xmlns:a="http://schemas.openxmlformats.org/drawingml/2006/main">
@@ -4108,7 +4108,7 @@
                 <a:ea typeface="Arial"/>
                 <a:cs typeface="Arial"/>
               </a:rPr>
-              <a:t>Stable demo + accessible source repository</a:t>
+              <a:t>Every claim links to recorded evidence</a:t>
             </a:r>
           </a:p>
         </p:txBody>
@@ -4118,7 +4118,7 @@
           <p:cNvPr id="9" name="">
             <a:extLst xmlns:a="http://schemas.openxmlformats.org/drawingml/2006/main">
               <a:ext uri="{FF2B5EF4-FFF2-40B4-BE49-F238E27FC236}">
-                <a16:creationId xmlns:a16="http://schemas.microsoft.com/office/drawing/2014/main" id="{4DA506A5-99C5-41E1-B7A0-3C8BA6826D2D}"/>
+                <a16:creationId xmlns:a16="http://schemas.microsoft.com/office/drawing/2014/main" id="{5323B80F-D50E-46D6-89E2-22F56CACA376}"/>
               </a:ext>
             </a:extLst>
           </p:cNvPr>
@@ -4165,7 +4165,7 @@
                 <a:ea typeface="Arial"/>
                 <a:cs typeface="Arial"/>
               </a:rPr>
-              <a:t>The available recording is rehearsal evidence; sponsor eligibility is pending.</a:t>
+              <a:t>Test assets only · CRE simulation + trusted relayer · judge access still required.</a:t>
             </a:r>
           </a:p>
         </p:txBody>
@@ -4173,7 +4173,7 @@
     </p:spTree>
     <p:extLst>
       <p:ext uri="{BB962C8B-B14F-4D97-AF65-F5344CB8AC3E}">
-        <p14:creationId xmlns:p14="http://schemas.microsoft.com/office/powerpoint/2010/main" val="1913468683"/>
+        <p14:creationId xmlns:p14="http://schemas.microsoft.com/office/powerpoint/2010/main" val="475116656"/>
       </p:ext>
     </p:extLst>
   </p:cSld>
@@ -4204,7 +4204,7 @@
           <p:cNvPr id="9" name="">
             <a:extLst xmlns:a="http://schemas.openxmlformats.org/drawingml/2006/main">
               <a:ext uri="{FF2B5EF4-FFF2-40B4-BE49-F238E27FC236}">
-                <a16:creationId xmlns:a16="http://schemas.microsoft.com/office/drawing/2014/main" id="{4108733D-9F26-4AB7-A250-1D5FD6E2F4DF}"/>
+                <a16:creationId xmlns:a16="http://schemas.microsoft.com/office/drawing/2014/main" id="{54965DB5-BC5C-4E16-8BDE-99188384CAFB}"/>
               </a:ext>
             </a:extLst>
           </p:cNvPr>
@@ -4261,7 +4261,7 @@
           <p:cNvPr id="2" name="">
             <a:extLst xmlns:a="http://schemas.openxmlformats.org/drawingml/2006/main">
               <a:ext uri="{FF2B5EF4-FFF2-40B4-BE49-F238E27FC236}">
-                <a16:creationId xmlns:a16="http://schemas.microsoft.com/office/drawing/2014/main" id="{71173B98-499F-497E-B494-0204CFDB0143}"/>
+                <a16:creationId xmlns:a16="http://schemas.microsoft.com/office/drawing/2014/main" id="{A0FD76F8-B30B-46FA-90E8-57AFD87CC075}"/>
               </a:ext>
             </a:extLst>
           </p:cNvPr>
@@ -4318,7 +4318,7 @@
           <p:cNvPr id="3" name="">
             <a:extLst xmlns:a="http://schemas.openxmlformats.org/drawingml/2006/main">
               <a:ext uri="{FF2B5EF4-FFF2-40B4-BE49-F238E27FC236}">
-                <a16:creationId xmlns:a16="http://schemas.microsoft.com/office/drawing/2014/main" id="{283EE33A-BFE5-44A1-BAA3-3361F40B6102}"/>
+                <a16:creationId xmlns:a16="http://schemas.microsoft.com/office/drawing/2014/main" id="{F4FDCA0E-E32F-46B8-A289-53953515BF44}"/>
               </a:ext>
             </a:extLst>
           </p:cNvPr>
@@ -4398,7 +4398,7 @@
           <p:cNvPr id="4" name="">
             <a:extLst xmlns:a="http://schemas.openxmlformats.org/drawingml/2006/main">
               <a:ext uri="{FF2B5EF4-FFF2-40B4-BE49-F238E27FC236}">
-                <a16:creationId xmlns:a16="http://schemas.microsoft.com/office/drawing/2014/main" id="{0800D71F-ACCD-4114-9203-32867FC70FB5}"/>
+                <a16:creationId xmlns:a16="http://schemas.microsoft.com/office/drawing/2014/main" id="{0014B6D1-01EF-4AB1-B0D3-4BB821974466}"/>
               </a:ext>
             </a:extLst>
           </p:cNvPr>
@@ -4455,7 +4455,7 @@
           <p:cNvPr id="5" name="">
             <a:extLst xmlns:a="http://schemas.openxmlformats.org/drawingml/2006/main">
               <a:ext uri="{FF2B5EF4-FFF2-40B4-BE49-F238E27FC236}">
-                <a16:creationId xmlns:a16="http://schemas.microsoft.com/office/drawing/2014/main" id="{65C020D7-8C2B-4550-A4E8-4C7A6039469A}"/>
+                <a16:creationId xmlns:a16="http://schemas.microsoft.com/office/drawing/2014/main" id="{901D0CE4-88BF-4F07-873F-C9496A72DB5D}"/>
               </a:ext>
             </a:extLst>
           </p:cNvPr>
@@ -4535,7 +4535,7 @@
           <p:cNvPr id="6" name="">
             <a:extLst xmlns:a="http://schemas.openxmlformats.org/drawingml/2006/main">
               <a:ext uri="{FF2B5EF4-FFF2-40B4-BE49-F238E27FC236}">
-                <a16:creationId xmlns:a16="http://schemas.microsoft.com/office/drawing/2014/main" id="{E6C0C757-09CE-4BFF-A2E0-614B8FE1D539}"/>
+                <a16:creationId xmlns:a16="http://schemas.microsoft.com/office/drawing/2014/main" id="{302D38C3-5130-456B-8167-32B03DF19DAD}"/>
               </a:ext>
             </a:extLst>
           </p:cNvPr>
@@ -4592,7 +4592,7 @@
           <p:cNvPr id="7" name="">
             <a:extLst xmlns:a="http://schemas.openxmlformats.org/drawingml/2006/main">
               <a:ext uri="{FF2B5EF4-FFF2-40B4-BE49-F238E27FC236}">
-                <a16:creationId xmlns:a16="http://schemas.microsoft.com/office/drawing/2014/main" id="{E418E00F-D84B-49AD-B26B-3237D4E365B5}"/>
+                <a16:creationId xmlns:a16="http://schemas.microsoft.com/office/drawing/2014/main" id="{36B1D57F-1123-45C0-9645-D17EECF91FC0}"/>
               </a:ext>
             </a:extLst>
           </p:cNvPr>
@@ -4639,7 +4639,7 @@
                 <a:ea typeface="Arial"/>
                 <a:cs typeface="Arial"/>
               </a:rPr>
-              <a:t>One genuine end-to-end order, then a judge-ready recording.</a:t>
+              <a:t>Judge access, durable hosting and verified stage playback.</a:t>
             </a:r>
           </a:p>
         </p:txBody>
@@ -4649,7 +4649,7 @@
           <p:cNvPr id="8" name="">
             <a:extLst xmlns:a="http://schemas.openxmlformats.org/drawingml/2006/main">
               <a:ext uri="{FF2B5EF4-FFF2-40B4-BE49-F238E27FC236}">
-                <a16:creationId xmlns:a16="http://schemas.microsoft.com/office/drawing/2014/main" id="{C66F3C21-97E6-4AFA-A39A-67C14C6A115F}"/>
+                <a16:creationId xmlns:a16="http://schemas.microsoft.com/office/drawing/2014/main" id="{7A392BA5-A64B-46EA-9097-ACBFA876FA64}"/>
               </a:ext>
             </a:extLst>
           </p:cNvPr>
@@ -4704,7 +4704,7 @@
     </p:spTree>
     <p:extLst>
       <p:ext uri="{BB962C8B-B14F-4D97-AF65-F5344CB8AC3E}">
-        <p14:creationId xmlns:p14="http://schemas.microsoft.com/office/powerpoint/2010/main" val="1315407178"/>
+        <p14:creationId xmlns:p14="http://schemas.microsoft.com/office/powerpoint/2010/main" val="271052609"/>
       </p:ext>
     </p:extLst>
   </p:cSld>

</xml_diff>